<commit_message>
Revisa documentação e prepara pacote de entrega
</commit_message>
<xml_diff>
--- a/APRESENTACAO_CP2.pptx
+++ b/APRESENTACAO_CP2.pptx
@@ -452,7 +452,7 @@
           <a:lstStyle xmlns:a="http://schemas.openxmlformats.org/drawingml/2006/main"/>
           <a:p xmlns:a="http://schemas.openxmlformats.org/drawingml/2006/main">
             <a:r>
-              <a:t>Apresentação do protótipo acadêmico. Fonte dos requisitos: CHECKPOINT 2.pdf fornecido pelo usuário.</a:t>
+              <a:t>Apresentação do protótipo acadêmico. Fonte dos requisitos: CHECKPOINT 2.pdf.</a:t>
             </a:r>
           </a:p>
         </p:txBody>
@@ -592,7 +592,7 @@
           <a:lstStyle xmlns:a="http://schemas.openxmlformats.org/drawingml/2006/main"/>
           <a:p xmlns:a="http://schemas.openxmlformats.org/drawingml/2006/main">
             <a:r>
-              <a:t>Distribuição sugerida. Todos devem saber explicar o fluxo. Arquivos TRELLO.md e docs/QUADRO_CP2.csv preparados. Links GitHub e Trello/Notion dependem de publicação nas contas do grupo.</a:t>
+              <a:t>Distribuição sugerida. Todos devem saber explicar o fluxo. Arquivos TRELLO.md e docs/QUADRO_CP2.csv preparados. GitHub: https://github.com/Cauasl17/prato-cheio-cp2. Quadro Trello/Notion pendente.</a:t>
             </a:r>
           </a:p>
         </p:txBody>

</xml_diff>